<commit_message>
[pe] fix themes fonts; fix layouts and settings
</commit_message>
<xml_diff>
--- a/slide/themes/src/13_alliance.pptx
+++ b/slide/themes/src/13_alliance.pptx
@@ -536,10 +536,7 @@
             <a:pPr>
               <a:defRPr/>
             </a:pPr>
-            <a:endParaRPr lang="en-US">
-              <a:latin typeface="Arial"/>
-              <a:cs typeface="Arial"/>
-            </a:endParaRPr>
+            <a:endParaRPr lang="en-US"/>
           </a:p>
         </p:txBody>
       </p:sp>

</xml_diff>